<commit_message>
?????????? ????? ??????????? (??? ??????)
</commit_message>
<xml_diff>
--- a/prezentacii/Karl-Linney-yarkaya.pptx
+++ b/prezentacii/Karl-Linney-yarkaya.pptx
@@ -128,7 +128,7 @@
         </p:nvSpPr>
         <p:spPr>
           <a:xfrm>
-            <a:off x="577850" y="965994"/>
+            <a:off x="577850" y="757436"/>
             <a:ext cx="2022872" cy="349250"/>
           </a:xfrm>
           <a:prstGeom prst="roundRect">
@@ -160,7 +160,7 @@
         </p:nvSpPr>
         <p:spPr>
           <a:xfrm>
-            <a:off x="711200" y="1023144"/>
+            <a:off x="711200" y="814586"/>
             <a:ext cx="1756172" cy="209550"/>
           </a:xfrm>
           <a:prstGeom prst="rect">
@@ -209,7 +209,7 @@
         </p:nvSpPr>
         <p:spPr>
           <a:xfrm>
-            <a:off x="571500" y="1606848"/>
+            <a:off x="571500" y="1398290"/>
             <a:ext cx="6096000" cy="1194792"/>
           </a:xfrm>
           <a:prstGeom prst="rect">
@@ -272,7 +272,7 @@
         </p:nvSpPr>
         <p:spPr>
           <a:xfrm>
-            <a:off x="571500" y="2855476"/>
+            <a:off x="571500" y="2646918"/>
             <a:ext cx="5324673" cy="257810"/>
           </a:xfrm>
           <a:prstGeom prst="rect">
@@ -315,13 +315,62 @@
       </p:sp>
       <p:sp>
         <p:nvSpPr>
-          <p:cNvPr id="7" name="Rounded Rectangle"/>
+          <p:cNvPr id="7" name="Text: Выполнила: Самушенко Вероника, ученица 5"/>
+          <p:cNvSpPr txBox="1"/>
+          <p:nvPr/>
+        </p:nvSpPr>
+        <p:spPr>
+          <a:xfrm>
+            <a:off x="571500" y="3088203"/>
+            <a:ext cx="4008537" cy="239395"/>
+          </a:xfrm>
+          <a:prstGeom prst="rect">
+            <a:avLst/>
+          </a:prstGeom>
+          <a:noFill/>
+        </p:spPr>
+        <p:txBody>
+          <a:bodyPr wrap="none" lIns="0" tIns="0" rIns="0" bIns="0" rtlCol="0" anchor="t">
+            <a:noAutofit/>
+          </a:bodyPr>
+          <a:lstStyle/>
+          <a:p>
+            <a:pPr algn="l">
+              <a:lnSpc>
+                <a:spcPts val="1885"/>
+              </a:lnSpc>
+              <a:spcBef>
+                <a:spcPts val="0"/>
+              </a:spcBef>
+              <a:spcAft>
+                <a:spcPts val="0"/>
+              </a:spcAft>
+              <a:buNone/>
+            </a:pPr>
+            <a:r>
+              <a:rPr lang="en-US" sz="1300" spc="-4" dirty="0">
+                <a:solidFill>
+                  <a:srgbClr val="2D1B4E"/>
+                </a:solidFill>
+                <a:latin typeface="Segoe UI"/>
+                <a:ea typeface="Segoe UI"/>
+                <a:cs typeface="Segoe UI"/>
+              </a:rPr>
+              <a:t>Выполнила: Самушенко Вероника, ученица 5г класса</a:t>
+            </a:r>
+            <a:endParaRPr lang="en-US" sz="1300" dirty="0"/>
+          </a:p>
+        </p:txBody>
+      </p:sp>
+      <p:sp>
+        <p:nvSpPr>
+          <p:cNvPr id="8" name="Rounded Rectangle"/>
           <p:cNvSpPr/>
           <p:nvPr/>
         </p:nvSpPr>
         <p:spPr>
           <a:xfrm rot="60000">
-            <a:off x="581025" y="3367881"/>
+            <a:off x="581025" y="3576439"/>
             <a:ext cx="2076451" cy="2520951"/>
           </a:xfrm>
           <a:prstGeom prst="roundRect">
@@ -345,7 +394,7 @@
       </p:sp>
       <p:pic>
         <p:nvPicPr>
-          <p:cNvPr id="8" name="Image: Портрет Карла Линнея"/>
+          <p:cNvPr id="9" name="Image: Портрет Карла Линнея"/>
           <p:cNvPicPr>
             <a:picLocks noChangeAspect="1"/>
           </p:cNvPicPr>
@@ -360,7 +409,7 @@
         </p:blipFill>
         <p:spPr>
           <a:xfrm rot="60000">
-            <a:off x="590550" y="3377406"/>
+            <a:off x="590550" y="3585964"/>
             <a:ext cx="2057401" cy="2501901"/>
           </a:xfrm>
           <a:prstGeom prst="rect">
@@ -3141,7 +3190,7 @@
         </p:nvSpPr>
         <p:spPr>
           <a:xfrm>
-            <a:off x="577850" y="1042194"/>
+            <a:off x="577850" y="839986"/>
             <a:ext cx="592138" cy="349250"/>
           </a:xfrm>
           <a:prstGeom prst="roundRect">
@@ -3173,7 +3222,7 @@
         </p:nvSpPr>
         <p:spPr>
           <a:xfrm>
-            <a:off x="711200" y="1099344"/>
+            <a:off x="711200" y="897136"/>
             <a:ext cx="325438" cy="209550"/>
           </a:xfrm>
           <a:prstGeom prst="rect">
@@ -3222,7 +3271,7 @@
         </p:nvSpPr>
         <p:spPr>
           <a:xfrm>
-            <a:off x="4083546" y="1670348"/>
+            <a:off x="4083546" y="1468140"/>
             <a:ext cx="4024809" cy="1194792"/>
           </a:xfrm>
           <a:prstGeom prst="rect">
@@ -3285,7 +3334,7 @@
         </p:nvSpPr>
         <p:spPr>
           <a:xfrm>
-            <a:off x="3533279" y="2906276"/>
+            <a:off x="3533279" y="2704068"/>
             <a:ext cx="5125442" cy="257810"/>
           </a:xfrm>
           <a:prstGeom prst="rect">
@@ -3328,13 +3377,62 @@
       </p:sp>
       <p:sp>
         <p:nvSpPr>
-          <p:cNvPr id="7" name="Rounded Rectangle"/>
+          <p:cNvPr id="7" name="Text: Выполнила: Самушенко Вероника, ученица 5"/>
+          <p:cNvSpPr txBox="1"/>
+          <p:nvPr/>
+        </p:nvSpPr>
+        <p:spPr>
+          <a:xfrm>
+            <a:off x="4091682" y="3132653"/>
+            <a:ext cx="4008537" cy="239395"/>
+          </a:xfrm>
+          <a:prstGeom prst="rect">
+            <a:avLst/>
+          </a:prstGeom>
+          <a:noFill/>
+        </p:spPr>
+        <p:txBody>
+          <a:bodyPr wrap="none" lIns="0" tIns="0" rIns="0" bIns="0" rtlCol="0" anchor="t">
+            <a:noAutofit/>
+          </a:bodyPr>
+          <a:lstStyle/>
+          <a:p>
+            <a:pPr algn="ctr">
+              <a:lnSpc>
+                <a:spcPts val="1885"/>
+              </a:lnSpc>
+              <a:spcBef>
+                <a:spcPts val="0"/>
+              </a:spcBef>
+              <a:spcAft>
+                <a:spcPts val="0"/>
+              </a:spcAft>
+              <a:buNone/>
+            </a:pPr>
+            <a:r>
+              <a:rPr lang="en-US" sz="1300" spc="-4" dirty="0">
+                <a:solidFill>
+                  <a:srgbClr val="2D1B4E"/>
+                </a:solidFill>
+                <a:latin typeface="Segoe UI"/>
+                <a:ea typeface="Segoe UI"/>
+                <a:cs typeface="Segoe UI"/>
+              </a:rPr>
+              <a:t>Выполнила: Самушенко Вероника, ученица 5г класса</a:t>
+            </a:r>
+            <a:endParaRPr lang="en-US" sz="1300" dirty="0"/>
+          </a:p>
+        </p:txBody>
+      </p:sp>
+      <p:sp>
+        <p:nvSpPr>
+          <p:cNvPr id="8" name="Rounded Rectangle"/>
           <p:cNvSpPr/>
           <p:nvPr/>
         </p:nvSpPr>
         <p:spPr>
           <a:xfrm rot="21540000">
-            <a:off x="5089525" y="3355181"/>
+            <a:off x="5089525" y="3557389"/>
             <a:ext cx="2012951" cy="2457451"/>
           </a:xfrm>
           <a:prstGeom prst="roundRect">
@@ -3358,7 +3456,7 @@
       </p:sp>
       <p:pic>
         <p:nvPicPr>
-          <p:cNvPr id="8" name="Image: Портрет Линнея"/>
+          <p:cNvPr id="9" name="Image: Портрет Линнея"/>
           <p:cNvPicPr>
             <a:picLocks noChangeAspect="1"/>
           </p:cNvPicPr>
@@ -3373,7 +3471,7 @@
         </p:blipFill>
         <p:spPr>
           <a:xfrm rot="21540000">
-            <a:off x="5099050" y="3364706"/>
+            <a:off x="5099050" y="3566914"/>
             <a:ext cx="1993901" cy="2438401"/>
           </a:xfrm>
           <a:prstGeom prst="rect">

</xml_diff>